<commit_message>
docs: met a jour le deck roadmap avec l avancement reel (phases 0-6 livrees)
Frise : phases 0-6 faites, 7 en cours ; chiffres mesures (main.js 5,93 ->
3,44 Mo, styles.css 18 o, build ~20 s) ; etat au 23/07 ; 876 specs.

Co-Authored-By: Claude Fable 5 <noreply@anthropic.com>
</commit_message>
<xml_diff>
--- a/docs/refactoring/ROADMAP-PERF-2026.pptx
+++ b/docs/refactoring/ROADMAP-PERF-2026.pptx
@@ -234,7 +234,7 @@
                     <c:v>Ph. 3 · styles</c:v>
                   </c:pt>
                   <c:pt idx="3">
-                    <c:v>Ph. 4+ · JS</c:v>
+                    <c:v>Ph. 4-6 · JS</c:v>
                   </c:pt>
                 </c:lvl>
               </c:multiLvlStrCache>
@@ -250,13 +250,13 @@
                   <c:v>5.93</c:v>
                 </c:pt>
                 <c:pt idx="1">
-                  <c:v>5.6</c:v>
+                  <c:v>5.85</c:v>
                 </c:pt>
                 <c:pt idx="2">
-                  <c:v>4.4</c:v>
+                  <c:v>3.53</c:v>
                 </c:pt>
                 <c:pt idx="3">
-                  <c:v>4.3</c:v>
+                  <c:v>3.44</c:v>
                 </c:pt>
               </c:numCache>
             </c:numRef>
@@ -4220,7 +4220,7 @@
                 <a:ea typeface="Calibri" pitchFamily="34" charset="-122"/>
                 <a:cs typeface="Calibri" pitchFamily="34" charset="-120"/>
               </a:rPr>
-              <a:t>Phase 0 livrée — plan persisté, baseline 14,7 Mo, outillage de mesure</a:t>
+              <a:t>Phases 0 → 6 livrées — esbuild, dédup styles, standalone, PlaybackState : main.js 5,93 → 3,44 Mo (−41 %)</a:t>
             </a:r>
             <a:endParaRPr lang="en-US" sz="1300" dirty="0"/>
           </a:p>
@@ -4308,7 +4308,7 @@
                 <a:ea typeface="Calibri" pitchFamily="34" charset="-122"/>
                 <a:cs typeface="Calibri" pitchFamily="34" charset="-120"/>
               </a:rPr>
-              <a:t>Phase 1 : code terminé (coalescing, hygiène deps, templates chauds) — validation des 856 specs en cours</a:t>
+              <a:t>Phase 7 : OnPush composant par composant — vague 1 (toast, messages, subtitles, time-bar) en cours</a:t>
             </a:r>
             <a:endParaRPr lang="en-US" sz="1300" dirty="0"/>
           </a:p>
@@ -4367,7 +4367,7 @@
                 <a:ea typeface="Calibri" pitchFamily="34" charset="-122"/>
                 <a:cs typeface="Calibri" pitchFamily="34" charset="-120"/>
               </a:rPr>
-              <a:t>Phases 2 → 10 : prêtes à dérouler, une livraison par phase, gates à chaque étape</a:t>
+              <a:t>Phases 8 → 10 : hors-zone + @defer transcription, zoneless, clôture — gates à chaque étape</a:t>
             </a:r>
             <a:endParaRPr lang="en-US" sz="1300" dirty="0"/>
           </a:p>
@@ -4538,7 +4538,7 @@
                 <a:ea typeface="Calibri" pitchFamily="34" charset="-122"/>
                 <a:cs typeface="Calibri" pitchFamily="34" charset="-120"/>
               </a:rPr>
-              <a:t>856 specs vertes</a:t>
+              <a:t>876 specs vertes</a:t>
             </a:r>
             <a:endParaRPr lang="en-US" sz="1200" dirty="0"/>
           </a:p>
@@ -8182,7 +8182,7 @@
           </a:solidFill>
           <a:ln w="34925">
             <a:solidFill>
-              <a:srgbClr val="FFFFFF"/>
+              <a:srgbClr val="3E9B6E"/>
             </a:solidFill>
             <a:prstDash val="solid"/>
           </a:ln>
@@ -8299,6 +8299,31 @@
         </p:nvSpPr>
         <p:spPr>
           <a:xfrm>
+            <a:off x="2735719" y="2958084"/>
+            <a:ext cx="667512" cy="667512"/>
+          </a:xfrm>
+          <a:prstGeom prst="ellipse">
+            <a:avLst/>
+          </a:prstGeom>
+          <a:solidFill>
+            <a:srgbClr val="0A2E3B"/>
+          </a:solidFill>
+          <a:ln w="34925">
+            <a:solidFill>
+              <a:srgbClr val="3E9B6E"/>
+            </a:solidFill>
+            <a:prstDash val="solid"/>
+          </a:ln>
+        </p:spPr>
+      </p:sp>
+      <p:sp>
+        <p:nvSpPr>
+          <p:cNvPr id="20" name="Shape 18"/>
+          <p:cNvSpPr/>
+          <p:nvPr/>
+        </p:nvSpPr>
+        <p:spPr>
+          <a:xfrm>
             <a:off x="2813443" y="3035808"/>
             <a:ext cx="512064" cy="512064"/>
           </a:xfrm>
@@ -8318,7 +8343,7 @@
       </p:sp>
       <p:sp>
         <p:nvSpPr>
-          <p:cNvPr id="20" name="Text 18"/>
+          <p:cNvPr id="21" name="Text 19"/>
           <p:cNvSpPr/>
           <p:nvPr/>
         </p:nvSpPr>
@@ -8357,7 +8382,7 @@
       </p:sp>
       <p:sp>
         <p:nvSpPr>
-          <p:cNvPr id="21" name="Text 19"/>
+          <p:cNvPr id="22" name="Text 20"/>
           <p:cNvSpPr/>
           <p:nvPr/>
         </p:nvSpPr>
@@ -8413,7 +8438,32 @@
       </p:sp>
       <p:sp>
         <p:nvSpPr>
-          <p:cNvPr id="22" name="Shape 20"/>
+          <p:cNvPr id="23" name="Shape 21"/>
+          <p:cNvSpPr/>
+          <p:nvPr/>
+        </p:nvSpPr>
+        <p:spPr>
+          <a:xfrm>
+            <a:off x="3744052" y="2958084"/>
+            <a:ext cx="667512" cy="667512"/>
+          </a:xfrm>
+          <a:prstGeom prst="ellipse">
+            <a:avLst/>
+          </a:prstGeom>
+          <a:solidFill>
+            <a:srgbClr val="0A2E3B"/>
+          </a:solidFill>
+          <a:ln w="34925">
+            <a:solidFill>
+              <a:srgbClr val="3E9B6E"/>
+            </a:solidFill>
+            <a:prstDash val="solid"/>
+          </a:ln>
+        </p:spPr>
+      </p:sp>
+      <p:sp>
+        <p:nvSpPr>
+          <p:cNvPr id="24" name="Shape 22"/>
           <p:cNvSpPr/>
           <p:nvPr/>
         </p:nvSpPr>
@@ -8438,7 +8488,7 @@
       </p:sp>
       <p:sp>
         <p:nvSpPr>
-          <p:cNvPr id="23" name="Text 21"/>
+          <p:cNvPr id="25" name="Text 23"/>
           <p:cNvSpPr/>
           <p:nvPr/>
         </p:nvSpPr>
@@ -8477,7 +8527,7 @@
       </p:sp>
       <p:sp>
         <p:nvSpPr>
-          <p:cNvPr id="24" name="Text 22"/>
+          <p:cNvPr id="26" name="Text 24"/>
           <p:cNvSpPr/>
           <p:nvPr/>
         </p:nvSpPr>
@@ -8533,7 +8583,32 @@
       </p:sp>
       <p:sp>
         <p:nvSpPr>
-          <p:cNvPr id="25" name="Shape 23"/>
+          <p:cNvPr id="27" name="Shape 25"/>
+          <p:cNvSpPr/>
+          <p:nvPr/>
+        </p:nvSpPr>
+        <p:spPr>
+          <a:xfrm>
+            <a:off x="4752386" y="2958084"/>
+            <a:ext cx="667512" cy="667512"/>
+          </a:xfrm>
+          <a:prstGeom prst="ellipse">
+            <a:avLst/>
+          </a:prstGeom>
+          <a:solidFill>
+            <a:srgbClr val="0A2E3B"/>
+          </a:solidFill>
+          <a:ln w="34925">
+            <a:solidFill>
+              <a:srgbClr val="3E9B6E"/>
+            </a:solidFill>
+            <a:prstDash val="solid"/>
+          </a:ln>
+        </p:spPr>
+      </p:sp>
+      <p:sp>
+        <p:nvSpPr>
+          <p:cNvPr id="28" name="Shape 26"/>
           <p:cNvSpPr/>
           <p:nvPr/>
         </p:nvSpPr>
@@ -8558,7 +8633,7 @@
       </p:sp>
       <p:sp>
         <p:nvSpPr>
-          <p:cNvPr id="26" name="Text 24"/>
+          <p:cNvPr id="29" name="Text 27"/>
           <p:cNvSpPr/>
           <p:nvPr/>
         </p:nvSpPr>
@@ -8597,7 +8672,7 @@
       </p:sp>
       <p:sp>
         <p:nvSpPr>
-          <p:cNvPr id="27" name="Text 25"/>
+          <p:cNvPr id="30" name="Text 28"/>
           <p:cNvSpPr/>
           <p:nvPr/>
         </p:nvSpPr>
@@ -8653,7 +8728,32 @@
       </p:sp>
       <p:sp>
         <p:nvSpPr>
-          <p:cNvPr id="28" name="Shape 26"/>
+          <p:cNvPr id="31" name="Shape 29"/>
+          <p:cNvSpPr/>
+          <p:nvPr/>
+        </p:nvSpPr>
+        <p:spPr>
+          <a:xfrm>
+            <a:off x="5760720" y="2958084"/>
+            <a:ext cx="667512" cy="667512"/>
+          </a:xfrm>
+          <a:prstGeom prst="ellipse">
+            <a:avLst/>
+          </a:prstGeom>
+          <a:solidFill>
+            <a:srgbClr val="0A2E3B"/>
+          </a:solidFill>
+          <a:ln w="34925">
+            <a:solidFill>
+              <a:srgbClr val="3E9B6E"/>
+            </a:solidFill>
+            <a:prstDash val="solid"/>
+          </a:ln>
+        </p:spPr>
+      </p:sp>
+      <p:sp>
+        <p:nvSpPr>
+          <p:cNvPr id="32" name="Shape 30"/>
           <p:cNvSpPr/>
           <p:nvPr/>
         </p:nvSpPr>
@@ -8678,7 +8778,7 @@
       </p:sp>
       <p:sp>
         <p:nvSpPr>
-          <p:cNvPr id="29" name="Text 27"/>
+          <p:cNvPr id="33" name="Text 31"/>
           <p:cNvSpPr/>
           <p:nvPr/>
         </p:nvSpPr>
@@ -8717,7 +8817,7 @@
       </p:sp>
       <p:sp>
         <p:nvSpPr>
-          <p:cNvPr id="30" name="Text 28"/>
+          <p:cNvPr id="34" name="Text 32"/>
           <p:cNvSpPr/>
           <p:nvPr/>
         </p:nvSpPr>
@@ -8756,7 +8856,32 @@
       </p:sp>
       <p:sp>
         <p:nvSpPr>
-          <p:cNvPr id="31" name="Shape 29"/>
+          <p:cNvPr id="35" name="Shape 33"/>
+          <p:cNvSpPr/>
+          <p:nvPr/>
+        </p:nvSpPr>
+        <p:spPr>
+          <a:xfrm>
+            <a:off x="6769054" y="2958084"/>
+            <a:ext cx="667512" cy="667512"/>
+          </a:xfrm>
+          <a:prstGeom prst="ellipse">
+            <a:avLst/>
+          </a:prstGeom>
+          <a:solidFill>
+            <a:srgbClr val="0A2E3B"/>
+          </a:solidFill>
+          <a:ln w="34925">
+            <a:solidFill>
+              <a:srgbClr val="3E9B6E"/>
+            </a:solidFill>
+            <a:prstDash val="solid"/>
+          </a:ln>
+        </p:spPr>
+      </p:sp>
+      <p:sp>
+        <p:nvSpPr>
+          <p:cNvPr id="36" name="Shape 34"/>
           <p:cNvSpPr/>
           <p:nvPr/>
         </p:nvSpPr>
@@ -8781,7 +8906,7 @@
       </p:sp>
       <p:sp>
         <p:nvSpPr>
-          <p:cNvPr id="32" name="Text 30"/>
+          <p:cNvPr id="37" name="Text 35"/>
           <p:cNvSpPr/>
           <p:nvPr/>
         </p:nvSpPr>
@@ -8820,7 +8945,7 @@
       </p:sp>
       <p:sp>
         <p:nvSpPr>
-          <p:cNvPr id="33" name="Text 31"/>
+          <p:cNvPr id="38" name="Text 36"/>
           <p:cNvSpPr/>
           <p:nvPr/>
         </p:nvSpPr>
@@ -8876,7 +9001,32 @@
       </p:sp>
       <p:sp>
         <p:nvSpPr>
-          <p:cNvPr id="34" name="Shape 32"/>
+          <p:cNvPr id="39" name="Shape 37"/>
+          <p:cNvSpPr/>
+          <p:nvPr/>
+        </p:nvSpPr>
+        <p:spPr>
+          <a:xfrm>
+            <a:off x="7777388" y="2958084"/>
+            <a:ext cx="667512" cy="667512"/>
+          </a:xfrm>
+          <a:prstGeom prst="ellipse">
+            <a:avLst/>
+          </a:prstGeom>
+          <a:solidFill>
+            <a:srgbClr val="0A2E3B"/>
+          </a:solidFill>
+          <a:ln w="34925">
+            <a:solidFill>
+              <a:srgbClr val="FFFFFF"/>
+            </a:solidFill>
+            <a:prstDash val="solid"/>
+          </a:ln>
+        </p:spPr>
+      </p:sp>
+      <p:sp>
+        <p:nvSpPr>
+          <p:cNvPr id="40" name="Shape 38"/>
           <p:cNvSpPr/>
           <p:nvPr/>
         </p:nvSpPr>
@@ -8901,7 +9051,7 @@
       </p:sp>
       <p:sp>
         <p:nvSpPr>
-          <p:cNvPr id="35" name="Text 33"/>
+          <p:cNvPr id="41" name="Text 39"/>
           <p:cNvSpPr/>
           <p:nvPr/>
         </p:nvSpPr>
@@ -8940,7 +9090,7 @@
       </p:sp>
       <p:sp>
         <p:nvSpPr>
-          <p:cNvPr id="36" name="Text 34"/>
+          <p:cNvPr id="42" name="Text 40"/>
           <p:cNvSpPr/>
           <p:nvPr/>
         </p:nvSpPr>
@@ -8996,7 +9146,7 @@
       </p:sp>
       <p:sp>
         <p:nvSpPr>
-          <p:cNvPr id="37" name="Shape 35"/>
+          <p:cNvPr id="43" name="Shape 41"/>
           <p:cNvSpPr/>
           <p:nvPr/>
         </p:nvSpPr>
@@ -9021,7 +9171,7 @@
       </p:sp>
       <p:sp>
         <p:nvSpPr>
-          <p:cNvPr id="38" name="Text 36"/>
+          <p:cNvPr id="44" name="Text 42"/>
           <p:cNvSpPr/>
           <p:nvPr/>
         </p:nvSpPr>
@@ -9060,7 +9210,7 @@
       </p:sp>
       <p:sp>
         <p:nvSpPr>
-          <p:cNvPr id="39" name="Text 37"/>
+          <p:cNvPr id="45" name="Text 43"/>
           <p:cNvSpPr/>
           <p:nvPr/>
         </p:nvSpPr>
@@ -9116,7 +9266,7 @@
       </p:sp>
       <p:sp>
         <p:nvSpPr>
-          <p:cNvPr id="40" name="Shape 38"/>
+          <p:cNvPr id="46" name="Shape 44"/>
           <p:cNvSpPr/>
           <p:nvPr/>
         </p:nvSpPr>
@@ -9141,7 +9291,7 @@
       </p:sp>
       <p:sp>
         <p:nvSpPr>
-          <p:cNvPr id="41" name="Text 39"/>
+          <p:cNvPr id="47" name="Text 45"/>
           <p:cNvSpPr/>
           <p:nvPr/>
         </p:nvSpPr>
@@ -9180,7 +9330,7 @@
       </p:sp>
       <p:sp>
         <p:nvSpPr>
-          <p:cNvPr id="42" name="Text 40"/>
+          <p:cNvPr id="48" name="Text 46"/>
           <p:cNvSpPr/>
           <p:nvPr/>
         </p:nvSpPr>
@@ -9219,7 +9369,7 @@
       </p:sp>
       <p:sp>
         <p:nvSpPr>
-          <p:cNvPr id="43" name="Shape 41"/>
+          <p:cNvPr id="49" name="Shape 47"/>
           <p:cNvSpPr/>
           <p:nvPr/>
         </p:nvSpPr>
@@ -9244,7 +9394,7 @@
       </p:sp>
       <p:sp>
         <p:nvSpPr>
-          <p:cNvPr id="44" name="Text 42"/>
+          <p:cNvPr id="50" name="Text 48"/>
           <p:cNvSpPr/>
           <p:nvPr/>
         </p:nvSpPr>
@@ -9283,7 +9433,7 @@
       </p:sp>
       <p:sp>
         <p:nvSpPr>
-          <p:cNvPr id="45" name="Text 43"/>
+          <p:cNvPr id="51" name="Text 49"/>
           <p:cNvSpPr/>
           <p:nvPr/>
         </p:nvSpPr>
@@ -9339,7 +9489,7 @@
       </p:sp>
       <p:sp>
         <p:nvSpPr>
-          <p:cNvPr id="46" name="Shape 44"/>
+          <p:cNvPr id="52" name="Shape 50"/>
           <p:cNvSpPr/>
           <p:nvPr/>
         </p:nvSpPr>
@@ -9364,7 +9514,7 @@
       </p:sp>
       <p:sp>
         <p:nvSpPr>
-          <p:cNvPr id="47" name="Text 45"/>
+          <p:cNvPr id="53" name="Text 51"/>
           <p:cNvSpPr/>
           <p:nvPr/>
         </p:nvSpPr>
@@ -9403,7 +9553,7 @@
       </p:sp>
       <p:sp>
         <p:nvSpPr>
-          <p:cNvPr id="48" name="Shape 46"/>
+          <p:cNvPr id="54" name="Shape 52"/>
           <p:cNvSpPr/>
           <p:nvPr/>
         </p:nvSpPr>
@@ -9428,7 +9578,7 @@
       </p:sp>
       <p:sp>
         <p:nvSpPr>
-          <p:cNvPr id="49" name="Text 47"/>
+          <p:cNvPr id="55" name="Text 53"/>
           <p:cNvSpPr/>
           <p:nvPr/>
         </p:nvSpPr>
@@ -9467,7 +9617,7 @@
       </p:sp>
       <p:sp>
         <p:nvSpPr>
-          <p:cNvPr id="50" name="Shape 48"/>
+          <p:cNvPr id="56" name="Shape 54"/>
           <p:cNvSpPr/>
           <p:nvPr/>
         </p:nvSpPr>
@@ -9487,7 +9637,7 @@
       </p:sp>
       <p:sp>
         <p:nvSpPr>
-          <p:cNvPr id="51" name="Text 49"/>
+          <p:cNvPr id="57" name="Text 55"/>
           <p:cNvSpPr/>
           <p:nvPr/>
         </p:nvSpPr>
@@ -9526,7 +9676,7 @@
       </p:sp>
       <p:sp>
         <p:nvSpPr>
-          <p:cNvPr id="52" name="Shape 50"/>
+          <p:cNvPr id="58" name="Shape 56"/>
           <p:cNvSpPr/>
           <p:nvPr/>
         </p:nvSpPr>
@@ -9546,7 +9696,7 @@
       </p:sp>
       <p:pic>
         <p:nvPicPr>
-          <p:cNvPr id="53" name="Image 0" descr="preencoded.png">    </p:cNvPr>
+          <p:cNvPr id="59" name="Image 0" descr="preencoded.png">    </p:cNvPr>
           <p:cNvPicPr>
             <a:picLocks noChangeAspect="1"/>
           </p:cNvPicPr>
@@ -9570,7 +9720,7 @@
       </p:pic>
       <p:sp>
         <p:nvSpPr>
-          <p:cNvPr id="54" name="Text 51"/>
+          <p:cNvPr id="60" name="Text 57"/>
           <p:cNvSpPr/>
           <p:nvPr/>
         </p:nvSpPr>
@@ -9615,7 +9765,7 @@
                 <a:ea typeface="Calibri" pitchFamily="34" charset="-122"/>
                 <a:cs typeface="Calibri" pitchFamily="34" charset="-120"/>
               </a:rPr>
-              <a:t>ng lint  ·  856 specs  ·  build production  ·  rapport de taille  ·  smoke checklist sur les samples</a:t>
+              <a:t>ng lint  ·  876 specs  ·  build production  ·  rapport de taille  ·  smoke checklist sur les samples</a:t>
             </a:r>
             <a:endParaRPr lang="en-US" sz="1200" dirty="0"/>
           </a:p>
@@ -9623,7 +9773,7 @@
       </p:sp>
       <p:sp>
         <p:nvSpPr>
-          <p:cNvPr id="55" name="Text 52"/>
+          <p:cNvPr id="61" name="Text 58"/>
           <p:cNvSpPr/>
           <p:nvPr/>
         </p:nvSpPr>
@@ -9662,7 +9812,7 @@
       </p:sp>
       <p:sp>
         <p:nvSpPr>
-          <p:cNvPr id="56" name="Text 53"/>
+          <p:cNvPr id="62" name="Text 59"/>
           <p:cNvSpPr/>
           <p:nvPr/>
         </p:nvSpPr>
@@ -9764,7 +9914,7 @@
                 <a:ea typeface="Calibri" pitchFamily="34" charset="-122"/>
                 <a:cs typeface="Calibri" pitchFamily="34" charset="-120"/>
               </a:rPr>
-              <a:t>CHANTIER A — PHASES 0 → 4</a:t>
+              <a:t>CHANTIER A — PHASES 0 → 4 · LIVRÉ</a:t>
             </a:r>
             <a:endParaRPr lang="en-US" sz="1050" dirty="0"/>
           </a:p>
@@ -10205,7 +10355,7 @@
           </a:solidFill>
           <a:ln w="28575">
             <a:solidFill>
-              <a:srgbClr val="E8A13D"/>
+              <a:srgbClr val="3E9B6E"/>
             </a:solidFill>
             <a:prstDash val="solid"/>
           </a:ln>
@@ -10227,8 +10377,8 @@
         </p:blipFill>
         <p:spPr>
           <a:xfrm>
-            <a:off x="7735824" y="2850185"/>
-            <a:ext cx="146304" cy="146304"/>
+            <a:off x="7731252" y="2845613"/>
+            <a:ext cx="155448" cy="155448"/>
           </a:xfrm>
           <a:prstGeom prst="rect">
             <a:avLst/>
@@ -10393,7 +10543,7 @@
                 <a:ea typeface="Calibri" pitchFamily="34" charset="-122"/>
                 <a:cs typeface="Calibri" pitchFamily="34" charset="-120"/>
               </a:rPr>
-              <a:t>@angular/build:application + karma moderne ; le concat devient copie + garde-fou anti-chunk (contrat mono-fichier).</a:t>
+              <a:t>@angular/build:application + karma moderne ; le concat devient copie + garde-fou anti-chunk ; EventEmitter interne (builtin Node banni).</a:t>
             </a:r>
             <a:endParaRPr lang="en-US" sz="1080" dirty="0"/>
           </a:p>
@@ -10407,21 +10557,50 @@
         </p:nvSpPr>
         <p:spPr>
           <a:xfrm>
-            <a:off x="7722108" y="3840480"/>
-            <a:ext cx="173736" cy="173736"/>
+            <a:off x="7680960" y="3799332"/>
+            <a:ext cx="256032" cy="256032"/>
           </a:xfrm>
           <a:prstGeom prst="ellipse">
             <a:avLst/>
           </a:prstGeom>
           <a:solidFill>
-            <a:srgbClr val="0B7698"/>
-          </a:solidFill>
-          <a:ln/>
-        </p:spPr>
-      </p:sp>
-      <p:sp>
-        <p:nvSpPr>
-          <p:cNvPr id="24" name="Shape 20"/>
+            <a:srgbClr val="FFFFFF"/>
+          </a:solidFill>
+          <a:ln w="28575">
+            <a:solidFill>
+              <a:srgbClr val="3E9B6E"/>
+            </a:solidFill>
+            <a:prstDash val="solid"/>
+          </a:ln>
+        </p:spPr>
+      </p:sp>
+      <p:pic>
+        <p:nvPicPr>
+          <p:cNvPr id="24" name="Image 2" descr="preencoded.png">    </p:cNvPr>
+          <p:cNvPicPr>
+            <a:picLocks noChangeAspect="1"/>
+          </p:cNvPicPr>
+          <p:nvPr/>
+        </p:nvPicPr>
+        <p:blipFill>
+          <a:blip r:embed="rId3"/>
+          <a:stretch>
+            <a:fillRect/>
+          </a:stretch>
+        </p:blipFill>
+        <p:spPr>
+          <a:xfrm>
+            <a:off x="7731252" y="3849624"/>
+            <a:ext cx="155448" cy="155448"/>
+          </a:xfrm>
+          <a:prstGeom prst="rect">
+            <a:avLst/>
+          </a:prstGeom>
+        </p:spPr>
+      </p:pic>
+      <p:sp>
+        <p:nvSpPr>
+          <p:cNvPr id="25" name="Shape 20"/>
           <p:cNvSpPr/>
           <p:nvPr/>
         </p:nvSpPr>
@@ -10448,7 +10627,7 @@
       </p:sp>
       <p:sp>
         <p:nvSpPr>
-          <p:cNvPr id="25" name="Shape 21"/>
+          <p:cNvPr id="26" name="Shape 21"/>
           <p:cNvSpPr/>
           <p:nvPr/>
         </p:nvSpPr>
@@ -10468,7 +10647,7 @@
       </p:sp>
       <p:sp>
         <p:nvSpPr>
-          <p:cNvPr id="26" name="Text 22"/>
+          <p:cNvPr id="27" name="Text 22"/>
           <p:cNvSpPr/>
           <p:nvPr/>
         </p:nvSpPr>
@@ -10507,7 +10686,7 @@
       </p:sp>
       <p:sp>
         <p:nvSpPr>
-          <p:cNvPr id="27" name="Text 23"/>
+          <p:cNvPr id="28" name="Text 23"/>
           <p:cNvSpPr/>
           <p:nvPr/>
         </p:nvSpPr>
@@ -10546,7 +10725,7 @@
       </p:sp>
       <p:sp>
         <p:nvSpPr>
-          <p:cNvPr id="28" name="Text 24"/>
+          <p:cNvPr id="29" name="Text 24"/>
           <p:cNvSpPr/>
           <p:nvPr/>
         </p:nvSpPr>
@@ -10585,27 +10764,56 @@
       </p:sp>
       <p:sp>
         <p:nvSpPr>
-          <p:cNvPr id="29" name="Shape 25"/>
-          <p:cNvSpPr/>
-          <p:nvPr/>
-        </p:nvSpPr>
-        <p:spPr>
-          <a:xfrm>
-            <a:off x="7722108" y="4844491"/>
-            <a:ext cx="173736" cy="173736"/>
+          <p:cNvPr id="30" name="Shape 25"/>
+          <p:cNvSpPr/>
+          <p:nvPr/>
+        </p:nvSpPr>
+        <p:spPr>
+          <a:xfrm>
+            <a:off x="7680960" y="4803343"/>
+            <a:ext cx="256032" cy="256032"/>
           </a:xfrm>
           <a:prstGeom prst="ellipse">
             <a:avLst/>
           </a:prstGeom>
           <a:solidFill>
-            <a:srgbClr val="0B7698"/>
-          </a:solidFill>
-          <a:ln/>
-        </p:spPr>
-      </p:sp>
-      <p:sp>
-        <p:nvSpPr>
-          <p:cNvPr id="30" name="Shape 26"/>
+            <a:srgbClr val="FFFFFF"/>
+          </a:solidFill>
+          <a:ln w="28575">
+            <a:solidFill>
+              <a:srgbClr val="3E9B6E"/>
+            </a:solidFill>
+            <a:prstDash val="solid"/>
+          </a:ln>
+        </p:spPr>
+      </p:sp>
+      <p:pic>
+        <p:nvPicPr>
+          <p:cNvPr id="31" name="Image 3" descr="preencoded.png">    </p:cNvPr>
+          <p:cNvPicPr>
+            <a:picLocks noChangeAspect="1"/>
+          </p:cNvPicPr>
+          <p:nvPr/>
+        </p:nvPicPr>
+        <p:blipFill>
+          <a:blip r:embed="rId4"/>
+          <a:stretch>
+            <a:fillRect/>
+          </a:stretch>
+        </p:blipFill>
+        <p:spPr>
+          <a:xfrm>
+            <a:off x="7731252" y="4853635"/>
+            <a:ext cx="155448" cy="155448"/>
+          </a:xfrm>
+          <a:prstGeom prst="rect">
+            <a:avLst/>
+          </a:prstGeom>
+        </p:spPr>
+      </p:pic>
+      <p:sp>
+        <p:nvSpPr>
+          <p:cNvPr id="32" name="Shape 26"/>
           <p:cNvSpPr/>
           <p:nvPr/>
         </p:nvSpPr>
@@ -10632,7 +10840,7 @@
       </p:sp>
       <p:sp>
         <p:nvSpPr>
-          <p:cNvPr id="31" name="Shape 27"/>
+          <p:cNvPr id="33" name="Shape 27"/>
           <p:cNvSpPr/>
           <p:nvPr/>
         </p:nvSpPr>
@@ -10652,7 +10860,7 @@
       </p:sp>
       <p:sp>
         <p:nvSpPr>
-          <p:cNvPr id="32" name="Text 28"/>
+          <p:cNvPr id="34" name="Text 28"/>
           <p:cNvSpPr/>
           <p:nvPr/>
         </p:nvSpPr>
@@ -10691,7 +10899,7 @@
       </p:sp>
       <p:sp>
         <p:nvSpPr>
-          <p:cNvPr id="33" name="Text 29"/>
+          <p:cNvPr id="35" name="Text 29"/>
           <p:cNvSpPr/>
           <p:nvPr/>
         </p:nvSpPr>
@@ -10730,7 +10938,7 @@
       </p:sp>
       <p:sp>
         <p:nvSpPr>
-          <p:cNvPr id="34" name="Text 30"/>
+          <p:cNvPr id="36" name="Text 30"/>
           <p:cNvSpPr/>
           <p:nvPr/>
         </p:nvSpPr>
@@ -10769,27 +10977,56 @@
       </p:sp>
       <p:sp>
         <p:nvSpPr>
-          <p:cNvPr id="35" name="Shape 31"/>
-          <p:cNvSpPr/>
-          <p:nvPr/>
-        </p:nvSpPr>
-        <p:spPr>
-          <a:xfrm>
-            <a:off x="7722108" y="5848502"/>
-            <a:ext cx="173736" cy="173736"/>
+          <p:cNvPr id="37" name="Shape 31"/>
+          <p:cNvSpPr/>
+          <p:nvPr/>
+        </p:nvSpPr>
+        <p:spPr>
+          <a:xfrm>
+            <a:off x="7680960" y="5807354"/>
+            <a:ext cx="256032" cy="256032"/>
           </a:xfrm>
           <a:prstGeom prst="ellipse">
             <a:avLst/>
           </a:prstGeom>
           <a:solidFill>
-            <a:srgbClr val="0B7698"/>
-          </a:solidFill>
-          <a:ln/>
-        </p:spPr>
-      </p:sp>
-      <p:sp>
-        <p:nvSpPr>
-          <p:cNvPr id="36" name="Shape 32"/>
+            <a:srgbClr val="FFFFFF"/>
+          </a:solidFill>
+          <a:ln w="28575">
+            <a:solidFill>
+              <a:srgbClr val="3E9B6E"/>
+            </a:solidFill>
+            <a:prstDash val="solid"/>
+          </a:ln>
+        </p:spPr>
+      </p:sp>
+      <p:pic>
+        <p:nvPicPr>
+          <p:cNvPr id="38" name="Image 4" descr="preencoded.png">    </p:cNvPr>
+          <p:cNvPicPr>
+            <a:picLocks noChangeAspect="1"/>
+          </p:cNvPicPr>
+          <p:nvPr/>
+        </p:nvPicPr>
+        <p:blipFill>
+          <a:blip r:embed="rId5"/>
+          <a:stretch>
+            <a:fillRect/>
+          </a:stretch>
+        </p:blipFill>
+        <p:spPr>
+          <a:xfrm>
+            <a:off x="7731252" y="5857646"/>
+            <a:ext cx="155448" cy="155448"/>
+          </a:xfrm>
+          <a:prstGeom prst="rect">
+            <a:avLst/>
+          </a:prstGeom>
+        </p:spPr>
+      </p:pic>
+      <p:sp>
+        <p:nvSpPr>
+          <p:cNvPr id="39" name="Shape 32"/>
           <p:cNvSpPr/>
           <p:nvPr/>
         </p:nvSpPr>
@@ -10816,7 +11053,7 @@
       </p:sp>
       <p:sp>
         <p:nvSpPr>
-          <p:cNvPr id="37" name="Text 33"/>
+          <p:cNvPr id="40" name="Text 33"/>
           <p:cNvSpPr/>
           <p:nvPr/>
         </p:nvSpPr>
@@ -10847,7 +11084,7 @@
                 <a:ea typeface="Calibri" pitchFamily="34" charset="-122"/>
                 <a:cs typeface="Calibri" pitchFamily="34" charset="-120"/>
               </a:rPr>
-              <a:t>GAIN ATTENDU</a:t>
+              <a:t>GAIN MESURÉ</a:t>
             </a:r>
             <a:endParaRPr lang="en-US" sz="1050" dirty="0"/>
           </a:p>
@@ -10855,7 +11092,7 @@
       </p:sp>
       <p:sp>
         <p:nvSpPr>
-          <p:cNvPr id="38" name="Text 34"/>
+          <p:cNvPr id="41" name="Text 34"/>
           <p:cNvSpPr/>
           <p:nvPr/>
         </p:nvSpPr>
@@ -10886,7 +11123,7 @@
                 <a:ea typeface="Trebuchet MS" pitchFamily="34" charset="-122"/>
                 <a:cs typeface="Trebuchet MS" pitchFamily="34" charset="-120"/>
               </a:rPr>
-              <a:t>−1,6 Mo</a:t>
+              <a:t>−2,45 Mo</a:t>
             </a:r>
             <a:endParaRPr lang="en-US" sz="4000" dirty="0"/>
           </a:p>
@@ -10894,7 +11131,7 @@
       </p:sp>
       <p:sp>
         <p:nvSpPr>
-          <p:cNvPr id="39" name="Text 35"/>
+          <p:cNvPr id="42" name="Text 35"/>
           <p:cNvSpPr/>
           <p:nvPr/>
         </p:nvSpPr>
@@ -10925,7 +11162,7 @@
                 <a:ea typeface="Calibri" pitchFamily="34" charset="-122"/>
                 <a:cs typeface="Calibri" pitchFamily="34" charset="-120"/>
               </a:rPr>
-              <a:t>sur main.js : 5,93 → ~4,3 Mo</a:t>
+              <a:t>sur main.js : 5,93 → 3,44 Mo (−41 %)</a:t>
             </a:r>
             <a:endParaRPr lang="en-US" sz="1200" dirty="0"/>
           </a:p>
@@ -10933,7 +11170,7 @@
       </p:sp>
       <p:sp>
         <p:nvSpPr>
-          <p:cNvPr id="40" name="Text 36"/>
+          <p:cNvPr id="43" name="Text 36"/>
           <p:cNvSpPr/>
           <p:nvPr/>
         </p:nvSpPr>
@@ -10968,7 +11205,7 @@
                 <a:ea typeface="Calibri" pitchFamily="34" charset="-122"/>
                 <a:cs typeface="Calibri" pitchFamily="34" charset="-120"/>
               </a:rPr>
-              <a:t>styles.css : 723 Ko → ~5 Ko</a:t>
+              <a:t>styles.css : 723 Ko → 18 octets</a:t>
             </a:r>
             <a:endParaRPr lang="en-US" sz="1150" dirty="0"/>
           </a:p>
@@ -11031,7 +11268,7 @@
                 <a:ea typeface="Calibri" pitchFamily="34" charset="-122"/>
                 <a:cs typeface="Calibri" pitchFamily="34" charset="-120"/>
               </a:rPr>
-              <a:t>Budgets angular.json enfin opérants</a:t>
+              <a:t>−396 paquets npm (toolchain Webpack)</a:t>
             </a:r>
             <a:endParaRPr lang="en-US" sz="1150" dirty="0"/>
           </a:p>
@@ -11039,7 +11276,7 @@
       </p:sp>
       <p:sp>
         <p:nvSpPr>
-          <p:cNvPr id="41" name="Text 37"/>
+          <p:cNvPr id="44" name="Text 37"/>
           <p:cNvSpPr/>
           <p:nvPr/>
         </p:nvSpPr>
@@ -11078,7 +11315,7 @@
       </p:sp>
       <p:sp>
         <p:nvSpPr>
-          <p:cNvPr id="42" name="Text 38"/>
+          <p:cNvPr id="45" name="Text 38"/>
           <p:cNvSpPr/>
           <p:nvPr/>
         </p:nvSpPr>
@@ -11180,7 +11417,7 @@
                 <a:ea typeface="Calibri" pitchFamily="34" charset="-122"/>
                 <a:cs typeface="Calibri" pitchFamily="34" charset="-120"/>
               </a:rPr>
-              <a:t>CHANTIER B — PHASES 5 → 8</a:t>
+              <a:t>CHANTIER B — PHASES 5 → 8 · EN COURS</a:t>
             </a:r>
             <a:endParaRPr lang="en-US" sz="1050" dirty="0"/>
           </a:p>
@@ -11397,21 +11634,50 @@
         </p:nvSpPr>
         <p:spPr>
           <a:xfrm>
-            <a:off x="7722108" y="1957959"/>
-            <a:ext cx="173736" cy="173736"/>
+            <a:off x="7680960" y="1916811"/>
+            <a:ext cx="256032" cy="256032"/>
           </a:xfrm>
           <a:prstGeom prst="ellipse">
             <a:avLst/>
           </a:prstGeom>
           <a:solidFill>
-            <a:srgbClr val="0B7698"/>
-          </a:solidFill>
-          <a:ln/>
-        </p:spPr>
-      </p:sp>
-      <p:sp>
-        <p:nvSpPr>
-          <p:cNvPr id="10" name="Shape 8"/>
+            <a:srgbClr val="FFFFFF"/>
+          </a:solidFill>
+          <a:ln w="28575">
+            <a:solidFill>
+              <a:srgbClr val="3E9B6E"/>
+            </a:solidFill>
+            <a:prstDash val="solid"/>
+          </a:ln>
+        </p:spPr>
+      </p:sp>
+      <p:pic>
+        <p:nvPicPr>
+          <p:cNvPr id="10" name="Image 0" descr="preencoded.png">    </p:cNvPr>
+          <p:cNvPicPr>
+            <a:picLocks noChangeAspect="1"/>
+          </p:cNvPicPr>
+          <p:nvPr/>
+        </p:nvPicPr>
+        <p:blipFill>
+          <a:blip r:embed="rId1"/>
+          <a:stretch>
+            <a:fillRect/>
+          </a:stretch>
+        </p:blipFill>
+        <p:spPr>
+          <a:xfrm>
+            <a:off x="7731252" y="1967103"/>
+            <a:ext cx="155448" cy="155448"/>
+          </a:xfrm>
+          <a:prstGeom prst="rect">
+            <a:avLst/>
+          </a:prstGeom>
+        </p:spPr>
+      </p:pic>
+      <p:sp>
+        <p:nvSpPr>
+          <p:cNvPr id="11" name="Shape 8"/>
           <p:cNvSpPr/>
           <p:nvPr/>
         </p:nvSpPr>
@@ -11438,7 +11704,7 @@
       </p:sp>
       <p:sp>
         <p:nvSpPr>
-          <p:cNvPr id="11" name="Shape 9"/>
+          <p:cNvPr id="12" name="Shape 9"/>
           <p:cNvSpPr/>
           <p:nvPr/>
         </p:nvSpPr>
@@ -11458,7 +11724,7 @@
       </p:sp>
       <p:sp>
         <p:nvSpPr>
-          <p:cNvPr id="12" name="Text 10"/>
+          <p:cNvPr id="13" name="Text 10"/>
           <p:cNvSpPr/>
           <p:nvPr/>
         </p:nvSpPr>
@@ -11497,7 +11763,7 @@
       </p:sp>
       <p:sp>
         <p:nvSpPr>
-          <p:cNvPr id="13" name="Text 11"/>
+          <p:cNvPr id="14" name="Text 11"/>
           <p:cNvSpPr/>
           <p:nvPr/>
         </p:nvSpPr>
@@ -11536,7 +11802,7 @@
       </p:sp>
       <p:sp>
         <p:nvSpPr>
-          <p:cNvPr id="14" name="Text 12"/>
+          <p:cNvPr id="15" name="Text 12"/>
           <p:cNvSpPr/>
           <p:nvPr/>
         </p:nvSpPr>
@@ -11575,27 +11841,56 @@
       </p:sp>
       <p:sp>
         <p:nvSpPr>
-          <p:cNvPr id="15" name="Shape 13"/>
-          <p:cNvSpPr/>
-          <p:nvPr/>
-        </p:nvSpPr>
-        <p:spPr>
-          <a:xfrm>
-            <a:off x="7722108" y="3212973"/>
-            <a:ext cx="173736" cy="173736"/>
+          <p:cNvPr id="16" name="Shape 13"/>
+          <p:cNvSpPr/>
+          <p:nvPr/>
+        </p:nvSpPr>
+        <p:spPr>
+          <a:xfrm>
+            <a:off x="7680960" y="3171825"/>
+            <a:ext cx="256032" cy="256032"/>
           </a:xfrm>
           <a:prstGeom prst="ellipse">
             <a:avLst/>
           </a:prstGeom>
           <a:solidFill>
-            <a:srgbClr val="0B7698"/>
-          </a:solidFill>
-          <a:ln/>
-        </p:spPr>
-      </p:sp>
-      <p:sp>
-        <p:nvSpPr>
-          <p:cNvPr id="16" name="Shape 14"/>
+            <a:srgbClr val="FFFFFF"/>
+          </a:solidFill>
+          <a:ln w="28575">
+            <a:solidFill>
+              <a:srgbClr val="3E9B6E"/>
+            </a:solidFill>
+            <a:prstDash val="solid"/>
+          </a:ln>
+        </p:spPr>
+      </p:sp>
+      <p:pic>
+        <p:nvPicPr>
+          <p:cNvPr id="17" name="Image 1" descr="preencoded.png">    </p:cNvPr>
+          <p:cNvPicPr>
+            <a:picLocks noChangeAspect="1"/>
+          </p:cNvPicPr>
+          <p:nvPr/>
+        </p:nvPicPr>
+        <p:blipFill>
+          <a:blip r:embed="rId2"/>
+          <a:stretch>
+            <a:fillRect/>
+          </a:stretch>
+        </p:blipFill>
+        <p:spPr>
+          <a:xfrm>
+            <a:off x="7731252" y="3222117"/>
+            <a:ext cx="155448" cy="155448"/>
+          </a:xfrm>
+          <a:prstGeom prst="rect">
+            <a:avLst/>
+          </a:prstGeom>
+        </p:spPr>
+      </p:pic>
+      <p:sp>
+        <p:nvSpPr>
+          <p:cNvPr id="18" name="Shape 14"/>
           <p:cNvSpPr/>
           <p:nvPr/>
         </p:nvSpPr>
@@ -11622,7 +11917,7 @@
       </p:sp>
       <p:sp>
         <p:nvSpPr>
-          <p:cNvPr id="17" name="Shape 15"/>
+          <p:cNvPr id="19" name="Shape 15"/>
           <p:cNvSpPr/>
           <p:nvPr/>
         </p:nvSpPr>
@@ -11642,7 +11937,7 @@
       </p:sp>
       <p:sp>
         <p:nvSpPr>
-          <p:cNvPr id="18" name="Text 16"/>
+          <p:cNvPr id="20" name="Text 16"/>
           <p:cNvSpPr/>
           <p:nvPr/>
         </p:nvSpPr>
@@ -11681,7 +11976,7 @@
       </p:sp>
       <p:sp>
         <p:nvSpPr>
-          <p:cNvPr id="19" name="Text 17"/>
+          <p:cNvPr id="21" name="Text 17"/>
           <p:cNvSpPr/>
           <p:nvPr/>
         </p:nvSpPr>
@@ -11720,7 +12015,7 @@
       </p:sp>
       <p:sp>
         <p:nvSpPr>
-          <p:cNvPr id="20" name="Text 18"/>
+          <p:cNvPr id="22" name="Text 18"/>
           <p:cNvSpPr/>
           <p:nvPr/>
         </p:nvSpPr>
@@ -11759,27 +12054,56 @@
       </p:sp>
       <p:sp>
         <p:nvSpPr>
-          <p:cNvPr id="21" name="Shape 19"/>
-          <p:cNvSpPr/>
-          <p:nvPr/>
-        </p:nvSpPr>
-        <p:spPr>
-          <a:xfrm>
-            <a:off x="7722108" y="4467987"/>
-            <a:ext cx="173736" cy="173736"/>
+          <p:cNvPr id="23" name="Shape 19"/>
+          <p:cNvSpPr/>
+          <p:nvPr/>
+        </p:nvSpPr>
+        <p:spPr>
+          <a:xfrm>
+            <a:off x="7680960" y="4426839"/>
+            <a:ext cx="256032" cy="256032"/>
           </a:xfrm>
           <a:prstGeom prst="ellipse">
             <a:avLst/>
           </a:prstGeom>
           <a:solidFill>
-            <a:srgbClr val="0B7698"/>
-          </a:solidFill>
-          <a:ln/>
-        </p:spPr>
-      </p:sp>
-      <p:sp>
-        <p:nvSpPr>
-          <p:cNvPr id="22" name="Shape 20"/>
+            <a:srgbClr val="FFFFFF"/>
+          </a:solidFill>
+          <a:ln w="28575">
+            <a:solidFill>
+              <a:srgbClr val="E8A13D"/>
+            </a:solidFill>
+            <a:prstDash val="solid"/>
+          </a:ln>
+        </p:spPr>
+      </p:sp>
+      <p:pic>
+        <p:nvPicPr>
+          <p:cNvPr id="24" name="Image 2" descr="preencoded.png">    </p:cNvPr>
+          <p:cNvPicPr>
+            <a:picLocks noChangeAspect="1"/>
+          </p:cNvPicPr>
+          <p:nvPr/>
+        </p:nvPicPr>
+        <p:blipFill>
+          <a:blip r:embed="rId3"/>
+          <a:stretch>
+            <a:fillRect/>
+          </a:stretch>
+        </p:blipFill>
+        <p:spPr>
+          <a:xfrm>
+            <a:off x="7735824" y="4481703"/>
+            <a:ext cx="146304" cy="146304"/>
+          </a:xfrm>
+          <a:prstGeom prst="rect">
+            <a:avLst/>
+          </a:prstGeom>
+        </p:spPr>
+      </p:pic>
+      <p:sp>
+        <p:nvSpPr>
+          <p:cNvPr id="25" name="Shape 20"/>
           <p:cNvSpPr/>
           <p:nvPr/>
         </p:nvSpPr>
@@ -11806,7 +12130,7 @@
       </p:sp>
       <p:sp>
         <p:nvSpPr>
-          <p:cNvPr id="23" name="Shape 21"/>
+          <p:cNvPr id="26" name="Shape 21"/>
           <p:cNvSpPr/>
           <p:nvPr/>
         </p:nvSpPr>
@@ -11826,7 +12150,7 @@
       </p:sp>
       <p:sp>
         <p:nvSpPr>
-          <p:cNvPr id="24" name="Text 22"/>
+          <p:cNvPr id="27" name="Text 22"/>
           <p:cNvSpPr/>
           <p:nvPr/>
         </p:nvSpPr>
@@ -11865,7 +12189,7 @@
       </p:sp>
       <p:sp>
         <p:nvSpPr>
-          <p:cNvPr id="25" name="Text 23"/>
+          <p:cNvPr id="28" name="Text 23"/>
           <p:cNvSpPr/>
           <p:nvPr/>
         </p:nvSpPr>
@@ -11904,7 +12228,7 @@
       </p:sp>
       <p:sp>
         <p:nvSpPr>
-          <p:cNvPr id="26" name="Text 24"/>
+          <p:cNvPr id="29" name="Text 24"/>
           <p:cNvSpPr/>
           <p:nvPr/>
         </p:nvSpPr>
@@ -11943,7 +12267,7 @@
       </p:sp>
       <p:sp>
         <p:nvSpPr>
-          <p:cNvPr id="27" name="Shape 25"/>
+          <p:cNvPr id="30" name="Shape 25"/>
           <p:cNvSpPr/>
           <p:nvPr/>
         </p:nvSpPr>
@@ -11963,7 +12287,7 @@
       </p:sp>
       <p:sp>
         <p:nvSpPr>
-          <p:cNvPr id="28" name="Shape 26"/>
+          <p:cNvPr id="31" name="Shape 26"/>
           <p:cNvSpPr/>
           <p:nvPr/>
         </p:nvSpPr>
@@ -11990,7 +12314,7 @@
       </p:sp>
       <p:sp>
         <p:nvSpPr>
-          <p:cNvPr id="29" name="Text 27"/>
+          <p:cNvPr id="32" name="Text 27"/>
           <p:cNvSpPr/>
           <p:nvPr/>
         </p:nvSpPr>
@@ -12029,7 +12353,7 @@
       </p:sp>
       <p:sp>
         <p:nvSpPr>
-          <p:cNvPr id="30" name="Text 28"/>
+          <p:cNvPr id="33" name="Text 28"/>
           <p:cNvSpPr/>
           <p:nvPr/>
         </p:nvSpPr>
@@ -12068,7 +12392,7 @@
       </p:sp>
       <p:sp>
         <p:nvSpPr>
-          <p:cNvPr id="31" name="Text 29"/>
+          <p:cNvPr id="34" name="Text 29"/>
           <p:cNvSpPr/>
           <p:nvPr/>
         </p:nvSpPr>
@@ -12107,7 +12431,7 @@
       </p:sp>
       <p:sp>
         <p:nvSpPr>
-          <p:cNvPr id="32" name="Text 30"/>
+          <p:cNvPr id="35" name="Text 30"/>
           <p:cNvSpPr/>
           <p:nvPr/>
         </p:nvSpPr>
@@ -12192,7 +12516,7 @@
       </p:sp>
       <p:sp>
         <p:nvSpPr>
-          <p:cNvPr id="33" name="Text 31"/>
+          <p:cNvPr id="36" name="Text 31"/>
           <p:cNvSpPr/>
           <p:nvPr/>
         </p:nvSpPr>
@@ -12231,7 +12555,7 @@
       </p:sp>
       <p:sp>
         <p:nvSpPr>
-          <p:cNvPr id="34" name="Text 32"/>
+          <p:cNvPr id="37" name="Text 32"/>
           <p:cNvSpPr/>
           <p:nvPr/>
         </p:nvSpPr>
@@ -13362,7 +13686,7 @@
                 <a:ea typeface="Calibri" pitchFamily="34" charset="-122"/>
                 <a:cs typeface="Calibri" pitchFamily="34" charset="-120"/>
               </a:rPr>
-              <a:t>PROJECTION</a:t>
+              <a:t>RÉSULTATS</a:t>
             </a:r>
             <a:endParaRPr lang="en-US" sz="1050" dirty="0"/>
           </a:p>
@@ -13440,7 +13764,7 @@
                 <a:ea typeface="Calibri" pitchFamily="34" charset="-122"/>
                 <a:cs typeface="Calibri" pitchFamily="34" charset="-120"/>
               </a:rPr>
-              <a:t>Tailles de main.js attendues par phase (Mo, non compressé) — suivies par scripts/size-report.mjs à chaque livraison.</a:t>
+              <a:t>Tailles de main.js mesurées par phase (Mo, non compressé) — suivies par scripts/size-report.mjs à chaque livraison.</a:t>
             </a:r>
             <a:endParaRPr lang="en-US" sz="1300" dirty="0"/>
           </a:p>
@@ -13608,7 +13932,7 @@
                 <a:ea typeface="Calibri" pitchFamily="34" charset="-122"/>
                 <a:cs typeface="Calibri" pitchFamily="34" charset="-120"/>
               </a:rPr>
-              <a:t>change detections par timeupdate</a:t>
+              <a:t>change detections par timeupdate (phase 7, en cours)</a:t>
             </a:r>
             <a:endParaRPr lang="en-US" sz="1100" dirty="0"/>
           </a:p>
@@ -13694,7 +14018,7 @@
                 <a:ea typeface="Trebuchet MS" pitchFamily="34" charset="-122"/>
                 <a:cs typeface="Trebuchet MS" pitchFamily="34" charset="-120"/>
               </a:rPr>
-              <a:t>723 Ko → ~5 Ko</a:t>
+              <a:t>723 Ko → 18 o</a:t>
             </a:r>
             <a:endParaRPr lang="en-US" sz="2100" dirty="0"/>
           </a:p>
@@ -13733,7 +14057,7 @@
                 <a:ea typeface="Calibri" pitchFamily="34" charset="-122"/>
                 <a:cs typeface="Calibri" pitchFamily="34" charset="-120"/>
               </a:rPr>
-              <a:t>styles.css global</a:t>
+              <a:t>styles.css global (fait)</a:t>
             </a:r>
             <a:endParaRPr lang="en-US" sz="1100" dirty="0"/>
           </a:p>
@@ -13858,7 +14182,7 @@
                 <a:ea typeface="Calibri" pitchFamily="34" charset="-122"/>
                 <a:cs typeface="Calibri" pitchFamily="34" charset="-120"/>
               </a:rPr>
-              <a:t>polices dans le dist</a:t>
+              <a:t>polices dans le dist (fait)</a:t>
             </a:r>
             <a:endParaRPr lang="en-US" sz="1100" dirty="0"/>
           </a:p>
@@ -13983,7 +14307,7 @@
                 <a:ea typeface="Calibri" pitchFamily="34" charset="-122"/>
                 <a:cs typeface="Calibri" pitchFamily="34" charset="-120"/>
               </a:rPr>
-              <a:t>build de production (Webpack → esbuild)</a:t>
+              <a:t>build de production (fait, Webpack → esbuild)</a:t>
             </a:r>
             <a:endParaRPr lang="en-US" sz="1100" dirty="0"/>
           </a:p>

</xml_diff>

<commit_message>
docs: CLAUDE.md et deck roadmap a jour de la fin du chantier perf
- CLAUDE.md : le chantier passe de "en cours" a "livre" ; regles perennes pour
  tout nouveau code (OnPush partout -> etat template en signals, politique de
  zone minimale, grille setTimeout, directives hors-zone, hydratation @defer
  transcription, sprite SVG) ; description du miroir PrimeNG corrigee
  (balises <style> en tete de shadow root, pas de CSSStyleSheet construites).
- Deck : frise 0-8 + 10 faites / 9 preparee (flip apres 1 cycle de release),
  chantier B livre (gain obtenu x7 -> 1), gates code coches, chart et etat
  au 10 aout (main.js 3,46 Mo, 887 specs).

Co-Authored-By: Claude Fable 5 <noreply@anthropic.com>
</commit_message>
<xml_diff>
--- a/docs/refactoring/ROADMAP-PERF-2026.pptx
+++ b/docs/refactoring/ROADMAP-PERF-2026.pptx
@@ -234,7 +234,7 @@
                     <c:v>Ph. 3 · styles</c:v>
                   </c:pt>
                   <c:pt idx="3">
-                    <c:v>Ph. 4-6 · JS</c:v>
+                    <c:v>Ph. 4-8</c:v>
                   </c:pt>
                 </c:lvl>
               </c:multiLvlStrCache>
@@ -256,7 +256,7 @@
                   <c:v>3.53</c:v>
                 </c:pt>
                 <c:pt idx="3">
-                  <c:v>3.44</c:v>
+                  <c:v>3.46</c:v>
                 </c:pt>
               </c:numCache>
             </c:numRef>
@@ -2661,7 +2661,7 @@
                 <a:ea typeface="Calibri" pitchFamily="34" charset="-122"/>
                 <a:cs typeface="Calibri" pitchFamily="34" charset="-120"/>
               </a:rPr>
-              <a:t>   ·   Juillet 2026</a:t>
+              <a:t>   ·   Juillet – Août 2026</a:t>
             </a:r>
             <a:endParaRPr lang="en-US" sz="1150" dirty="0"/>
           </a:p>
@@ -2884,7 +2884,7 @@
       </p:sp>
       <p:pic>
         <p:nvPicPr>
-          <p:cNvPr id="7" name="Image 0" descr="preencoded.png">    </p:cNvPr>
+          <p:cNvPr id="7" name="Image 0" descr="preencoded.png"/>
           <p:cNvPicPr>
             <a:picLocks noChangeAspect="1"/>
           </p:cNvPicPr>
@@ -2970,7 +2970,7 @@
       </p:sp>
       <p:pic>
         <p:nvPicPr>
-          <p:cNvPr id="10" name="Image 1" descr="preencoded.png">    </p:cNvPr>
+          <p:cNvPr id="10" name="Image 1" descr="preencoded.png"/>
           <p:cNvPicPr>
             <a:picLocks noChangeAspect="1"/>
           </p:cNvPicPr>
@@ -3060,7 +3060,7 @@
       </p:sp>
       <p:pic>
         <p:nvPicPr>
-          <p:cNvPr id="13" name="Image 2" descr="preencoded.png">    </p:cNvPr>
+          <p:cNvPr id="13" name="Image 2" descr="preencoded.png"/>
           <p:cNvPicPr>
             <a:picLocks noChangeAspect="1"/>
           </p:cNvPicPr>
@@ -3146,7 +3146,7 @@
       </p:sp>
       <p:pic>
         <p:nvPicPr>
-          <p:cNvPr id="16" name="Image 3" descr="preencoded.png">    </p:cNvPr>
+          <p:cNvPr id="16" name="Image 3" descr="preencoded.png"/>
           <p:cNvPicPr>
             <a:picLocks noChangeAspect="1"/>
           </p:cNvPicPr>
@@ -3236,7 +3236,7 @@
       </p:sp>
       <p:pic>
         <p:nvPicPr>
-          <p:cNvPr id="19" name="Image 4" descr="preencoded.png">    </p:cNvPr>
+          <p:cNvPr id="19" name="Image 4" descr="preencoded.png"/>
           <p:cNvPicPr>
             <a:picLocks noChangeAspect="1"/>
           </p:cNvPicPr>
@@ -3322,7 +3322,7 @@
       </p:sp>
       <p:pic>
         <p:nvPicPr>
-          <p:cNvPr id="22" name="Image 5" descr="preencoded.png">    </p:cNvPr>
+          <p:cNvPr id="22" name="Image 5" descr="preencoded.png"/>
           <p:cNvPicPr>
             <a:picLocks noChangeAspect="1"/>
           </p:cNvPicPr>
@@ -3412,7 +3412,7 @@
       </p:sp>
       <p:pic>
         <p:nvPicPr>
-          <p:cNvPr id="25" name="Image 6" descr="preencoded.png">    </p:cNvPr>
+          <p:cNvPr id="25" name="Image 6" descr="preencoded.png"/>
           <p:cNvPicPr>
             <a:picLocks noChangeAspect="1"/>
           </p:cNvPicPr>
@@ -3498,7 +3498,7 @@
       </p:sp>
       <p:pic>
         <p:nvPicPr>
-          <p:cNvPr id="28" name="Image 7" descr="preencoded.png">    </p:cNvPr>
+          <p:cNvPr id="28" name="Image 7" descr="preencoded.png"/>
           <p:cNvPicPr>
             <a:picLocks noChangeAspect="1"/>
           </p:cNvPicPr>
@@ -3588,7 +3588,7 @@
       </p:sp>
       <p:pic>
         <p:nvPicPr>
-          <p:cNvPr id="31" name="Image 8" descr="preencoded.png">    </p:cNvPr>
+          <p:cNvPr id="31" name="Image 8" descr="preencoded.png"/>
           <p:cNvPicPr>
             <a:picLocks noChangeAspect="1"/>
           </p:cNvPicPr>
@@ -3674,7 +3674,7 @@
       </p:sp>
       <p:pic>
         <p:nvPicPr>
-          <p:cNvPr id="34" name="Image 9" descr="preencoded.png">    </p:cNvPr>
+          <p:cNvPr id="34" name="Image 9" descr="preencoded.png"/>
           <p:cNvPicPr>
             <a:picLocks noChangeAspect="1"/>
           </p:cNvPicPr>
@@ -4132,7 +4132,7 @@
                 <a:ea typeface="Calibri" pitchFamily="34" charset="-122"/>
                 <a:cs typeface="Calibri" pitchFamily="34" charset="-120"/>
               </a:rPr>
-              <a:t>ÉTAT AU 23 JUILLET 2026</a:t>
+              <a:t>ÉTAT AU 10 AOÛT 2026</a:t>
             </a:r>
             <a:endParaRPr lang="en-US" sz="1050" dirty="0"/>
           </a:p>
@@ -4165,7 +4165,7 @@
       </p:sp>
       <p:pic>
         <p:nvPicPr>
-          <p:cNvPr id="14" name="Image 0" descr="preencoded.png">    </p:cNvPr>
+          <p:cNvPr id="14" name="Image 0" descr="preencoded.png"/>
           <p:cNvPicPr>
             <a:picLocks noChangeAspect="1"/>
           </p:cNvPicPr>
@@ -4220,7 +4220,7 @@
                 <a:ea typeface="Calibri" pitchFamily="34" charset="-122"/>
                 <a:cs typeface="Calibri" pitchFamily="34" charset="-120"/>
               </a:rPr>
-              <a:t>Phases 0 → 6 livrées — esbuild, dédup styles, standalone, PlaybackState : main.js 5,93 → 3,44 Mo (−41 %)</a:t>
+              <a:t>Phases 0 → 8 + 10 livrées — esbuild, dédup styles, standalone, signals, 13/13 OnPush, @defer : main.js 5,93 → 3,46 Mo (−41 %)</a:t>
             </a:r>
             <a:endParaRPr lang="en-US" sz="1300" dirty="0"/>
           </a:p>
@@ -4253,7 +4253,7 @@
       </p:sp>
       <p:pic>
         <p:nvPicPr>
-          <p:cNvPr id="17" name="Image 1" descr="preencoded.png">    </p:cNvPr>
+          <p:cNvPr id="17" name="Image 1" descr="preencoded.png"/>
           <p:cNvPicPr>
             <a:picLocks noChangeAspect="1"/>
           </p:cNvPicPr>
@@ -4308,7 +4308,7 @@
                 <a:ea typeface="Calibri" pitchFamily="34" charset="-122"/>
                 <a:cs typeface="Calibri" pitchFamily="34" charset="-120"/>
               </a:rPr>
-              <a:t>Phase 7 : OnPush composant par composant — vague 1 (toast, messages, subtitles, time-bar) en cours</a:t>
+              <a:t>Phase 9 zoneless : préparée (ng serve -c zoneless) — flip final après ≥ 1 cycle de release en prod</a:t>
             </a:r>
             <a:endParaRPr lang="en-US" sz="1300" dirty="0"/>
           </a:p>
@@ -4367,7 +4367,7 @@
                 <a:ea typeface="Calibri" pitchFamily="34" charset="-122"/>
                 <a:cs typeface="Calibri" pitchFamily="34" charset="-120"/>
               </a:rPr>
-              <a:t>Phases 8 → 10 : hors-zone + @defer transcription, zoneless, clôture — gates à chaque étape</a:t>
+              <a:t>Avant merge : smoke test visuel (SMOKE-CHECKLIST.md) sur les samples, puis merge vers develop</a:t>
             </a:r>
             <a:endParaRPr lang="en-US" sz="1300" dirty="0"/>
           </a:p>
@@ -4538,7 +4538,7 @@
                 <a:ea typeface="Calibri" pitchFamily="34" charset="-122"/>
                 <a:cs typeface="Calibri" pitchFamily="34" charset="-120"/>
               </a:rPr>
-              <a:t>876 specs vertes</a:t>
+              <a:t>887 specs vertes</a:t>
             </a:r>
             <a:endParaRPr lang="en-US" sz="1200" dirty="0"/>
           </a:p>
@@ -5634,7 +5634,7 @@
       </p:sp>
       <p:pic>
         <p:nvPicPr>
-          <p:cNvPr id="26" name="Image 0" descr="preencoded.png">    </p:cNvPr>
+          <p:cNvPr id="26" name="Image 0" descr="preencoded.png"/>
           <p:cNvPicPr>
             <a:picLocks noChangeAspect="1"/>
           </p:cNvPicPr>
@@ -5946,7 +5946,7 @@
       </p:sp>
       <p:pic>
         <p:nvPicPr>
-          <p:cNvPr id="6" name="Image 0" descr="preencoded.png">    </p:cNvPr>
+          <p:cNvPr id="6" name="Image 0" descr="preencoded.png"/>
           <p:cNvPicPr>
             <a:picLocks noChangeAspect="1"/>
           </p:cNvPicPr>
@@ -6158,7 +6158,7 @@
       </p:sp>
       <p:pic>
         <p:nvPicPr>
-          <p:cNvPr id="11" name="Image 1" descr="preencoded.png">    </p:cNvPr>
+          <p:cNvPr id="11" name="Image 1" descr="preencoded.png"/>
           <p:cNvPicPr>
             <a:picLocks noChangeAspect="1"/>
           </p:cNvPicPr>
@@ -6370,7 +6370,7 @@
       </p:sp>
       <p:pic>
         <p:nvPicPr>
-          <p:cNvPr id="16" name="Image 2" descr="preencoded.png">    </p:cNvPr>
+          <p:cNvPr id="16" name="Image 2" descr="preencoded.png"/>
           <p:cNvPicPr>
             <a:picLocks noChangeAspect="1"/>
           </p:cNvPicPr>
@@ -7543,7 +7543,7 @@
       </p:sp>
       <p:pic>
         <p:nvPicPr>
-          <p:cNvPr id="29" name="Image 0" descr="preencoded.png">    </p:cNvPr>
+          <p:cNvPr id="29" name="Image 0" descr="preencoded.png"/>
           <p:cNvPicPr>
             <a:picLocks noChangeAspect="1"/>
           </p:cNvPicPr>
@@ -8753,6 +8753,31 @@
       </p:sp>
       <p:sp>
         <p:nvSpPr>
+          <p:cNvPr id="9010" name="RingStatus10"/>
+          <p:cNvSpPr/>
+          <p:nvPr/>
+        </p:nvSpPr>
+        <p:spPr>
+          <a:xfrm>
+            <a:off x="10802391" y="2958084"/>
+            <a:ext cx="667512" cy="667512"/>
+          </a:xfrm>
+          <a:prstGeom prst="ellipse">
+            <a:avLst/>
+          </a:prstGeom>
+          <a:solidFill>
+            <a:srgbClr val="0A2E3B"/>
+          </a:solidFill>
+          <a:ln w="34925">
+            <a:solidFill>
+              <a:srgbClr val="3E9B6E"/>
+            </a:solidFill>
+            <a:prstDash val="solid"/>
+          </a:ln>
+        </p:spPr>
+      </p:sp>
+      <p:sp>
+        <p:nvSpPr>
           <p:cNvPr id="32" name="Shape 30"/>
           <p:cNvSpPr/>
           <p:nvPr/>
@@ -9018,7 +9043,7 @@
           </a:solidFill>
           <a:ln w="34925">
             <a:solidFill>
-              <a:srgbClr val="FFFFFF"/>
+              <a:srgbClr val="3E9B6E"/>
             </a:solidFill>
             <a:prstDash val="solid"/>
           </a:ln>
@@ -9146,6 +9171,31 @@
       </p:sp>
       <p:sp>
         <p:nvSpPr>
+          <p:cNvPr id="9008" name="RingStatus8"/>
+          <p:cNvSpPr/>
+          <p:nvPr/>
+        </p:nvSpPr>
+        <p:spPr>
+          <a:xfrm>
+            <a:off x="8785723" y="2958084"/>
+            <a:ext cx="667512" cy="667512"/>
+          </a:xfrm>
+          <a:prstGeom prst="ellipse">
+            <a:avLst/>
+          </a:prstGeom>
+          <a:solidFill>
+            <a:srgbClr val="0A2E3B"/>
+          </a:solidFill>
+          <a:ln w="34925">
+            <a:solidFill>
+              <a:srgbClr val="3E9B6E"/>
+            </a:solidFill>
+            <a:prstDash val="solid"/>
+          </a:ln>
+        </p:spPr>
+      </p:sp>
+      <p:sp>
+        <p:nvSpPr>
           <p:cNvPr id="43" name="Shape 41"/>
           <p:cNvSpPr/>
           <p:nvPr/>
@@ -9266,6 +9316,31 @@
       </p:sp>
       <p:sp>
         <p:nvSpPr>
+          <p:cNvPr id="9009" name="RingStatus9"/>
+          <p:cNvSpPr/>
+          <p:nvPr/>
+        </p:nvSpPr>
+        <p:spPr>
+          <a:xfrm>
+            <a:off x="9794057" y="2958084"/>
+            <a:ext cx="667512" cy="667512"/>
+          </a:xfrm>
+          <a:prstGeom prst="ellipse">
+            <a:avLst/>
+          </a:prstGeom>
+          <a:solidFill>
+            <a:srgbClr val="0A2E3B"/>
+          </a:solidFill>
+          <a:ln w="34925">
+            <a:solidFill>
+              <a:srgbClr val="FFFFFF"/>
+            </a:solidFill>
+            <a:prstDash val="solid"/>
+          </a:ln>
+        </p:spPr>
+      </p:sp>
+      <p:sp>
+        <p:nvSpPr>
           <p:cNvPr id="46" name="Shape 44"/>
           <p:cNvSpPr/>
           <p:nvPr/>
@@ -9609,66 +9684,7 @@
                 <a:ea typeface="Calibri" pitchFamily="34" charset="-122"/>
                 <a:cs typeface="Calibri" pitchFamily="34" charset="-120"/>
               </a:rPr>
-              <a:t>en cours</a:t>
-            </a:r>
-            <a:endParaRPr lang="en-US" sz="1050" dirty="0"/>
-          </a:p>
-        </p:txBody>
-      </p:sp>
-      <p:sp>
-        <p:nvSpPr>
-          <p:cNvPr id="56" name="Shape 54"/>
-          <p:cNvSpPr/>
-          <p:nvPr/>
-        </p:nvSpPr>
-        <p:spPr>
-          <a:xfrm>
-            <a:off x="2944368" y="4846320"/>
-            <a:ext cx="219456" cy="219456"/>
-          </a:xfrm>
-          <a:prstGeom prst="ellipse">
-            <a:avLst/>
-          </a:prstGeom>
-          <a:solidFill>
-            <a:srgbClr val="0B7698"/>
-          </a:solidFill>
-          <a:ln/>
-        </p:spPr>
-      </p:sp>
-      <p:sp>
-        <p:nvSpPr>
-          <p:cNvPr id="57" name="Text 55"/>
-          <p:cNvSpPr/>
-          <p:nvPr/>
-        </p:nvSpPr>
-        <p:spPr>
-          <a:xfrm>
-            <a:off x="3255264" y="4828032"/>
-            <a:ext cx="914400" cy="256032"/>
-          </a:xfrm>
-          <a:prstGeom prst="rect">
-            <a:avLst/>
-          </a:prstGeom>
-          <a:noFill/>
-          <a:ln/>
-        </p:spPr>
-        <p:txBody>
-          <a:bodyPr wrap="square" lIns="0" tIns="0" rIns="0" bIns="0" rtlCol="0" anchor="ctr"/>
-          <a:lstStyle/>
-          <a:p>
-            <a:pPr indent="0" marL="0">
-              <a:buNone/>
-            </a:pPr>
-            <a:r>
-              <a:rPr lang="en-US" sz="1050" dirty="0">
-                <a:solidFill>
-                  <a:srgbClr val="9CC3D2"/>
-                </a:solidFill>
-                <a:latin typeface="Calibri" pitchFamily="34" charset="0"/>
-                <a:ea typeface="Calibri" pitchFamily="34" charset="-122"/>
-                <a:cs typeface="Calibri" pitchFamily="34" charset="-120"/>
-              </a:rPr>
-              <a:t>à venir</a:t>
+              <a:t>préparée</a:t>
             </a:r>
             <a:endParaRPr lang="en-US" sz="1050" dirty="0"/>
           </a:p>
@@ -9696,7 +9712,7 @@
       </p:sp>
       <p:pic>
         <p:nvPicPr>
-          <p:cNvPr id="59" name="Image 0" descr="preencoded.png">    </p:cNvPr>
+          <p:cNvPr id="59" name="Image 0" descr="preencoded.png"/>
           <p:cNvPicPr>
             <a:picLocks noChangeAspect="1"/>
           </p:cNvPicPr>
@@ -9765,7 +9781,7 @@
                 <a:ea typeface="Calibri" pitchFamily="34" charset="-122"/>
                 <a:cs typeface="Calibri" pitchFamily="34" charset="-120"/>
               </a:rPr>
-              <a:t>ng lint  ·  876 specs  ·  build production  ·  rapport de taille  ·  smoke checklist sur les samples</a:t>
+              <a:t>ng lint  ·  887 specs  ·  build production  ·  rapport de taille  ·  smoke checklist sur les samples</a:t>
             </a:r>
             <a:endParaRPr lang="en-US" sz="1200" dirty="0"/>
           </a:p>
@@ -10150,7 +10166,7 @@
       </p:sp>
       <p:pic>
         <p:nvPicPr>
-          <p:cNvPr id="10" name="Image 0" descr="preencoded.png">    </p:cNvPr>
+          <p:cNvPr id="10" name="Image 0" descr="preencoded.png"/>
           <p:cNvPicPr>
             <a:picLocks noChangeAspect="1"/>
           </p:cNvPicPr>
@@ -10363,7 +10379,7 @@
       </p:sp>
       <p:pic>
         <p:nvPicPr>
-          <p:cNvPr id="17" name="Image 1" descr="preencoded.png">    </p:cNvPr>
+          <p:cNvPr id="17" name="Image 1" descr="preencoded.png"/>
           <p:cNvPicPr>
             <a:picLocks noChangeAspect="1"/>
           </p:cNvPicPr>
@@ -10576,7 +10592,7 @@
       </p:sp>
       <p:pic>
         <p:nvPicPr>
-          <p:cNvPr id="24" name="Image 2" descr="preencoded.png">    </p:cNvPr>
+          <p:cNvPr id="24" name="Image 2" descr="preencoded.png"/>
           <p:cNvPicPr>
             <a:picLocks noChangeAspect="1"/>
           </p:cNvPicPr>
@@ -10789,7 +10805,7 @@
       </p:sp>
       <p:pic>
         <p:nvPicPr>
-          <p:cNvPr id="31" name="Image 3" descr="preencoded.png">    </p:cNvPr>
+          <p:cNvPr id="31" name="Image 3" descr="preencoded.png"/>
           <p:cNvPicPr>
             <a:picLocks noChangeAspect="1"/>
           </p:cNvPicPr>
@@ -11002,7 +11018,7 @@
       </p:sp>
       <p:pic>
         <p:nvPicPr>
-          <p:cNvPr id="38" name="Image 4" descr="preencoded.png">    </p:cNvPr>
+          <p:cNvPr id="38" name="Image 4" descr="preencoded.png"/>
           <p:cNvPicPr>
             <a:picLocks noChangeAspect="1"/>
           </p:cNvPicPr>
@@ -11417,7 +11433,7 @@
                 <a:ea typeface="Calibri" pitchFamily="34" charset="-122"/>
                 <a:cs typeface="Calibri" pitchFamily="34" charset="-120"/>
               </a:rPr>
-              <a:t>CHANTIER B — PHASES 5 → 8 · EN COURS</a:t>
+              <a:t>CHANTIER B — PHASES 5 → 8 · LIVRÉ</a:t>
             </a:r>
             <a:endParaRPr lang="en-US" sz="1050" dirty="0"/>
           </a:p>
@@ -11653,7 +11669,7 @@
       </p:sp>
       <p:pic>
         <p:nvPicPr>
-          <p:cNvPr id="10" name="Image 0" descr="preencoded.png">    </p:cNvPr>
+          <p:cNvPr id="10" name="Image 0" descr="preencoded.png"/>
           <p:cNvPicPr>
             <a:picLocks noChangeAspect="1"/>
           </p:cNvPicPr>
@@ -11866,7 +11882,7 @@
       </p:sp>
       <p:pic>
         <p:nvPicPr>
-          <p:cNvPr id="17" name="Image 1" descr="preencoded.png">    </p:cNvPr>
+          <p:cNvPr id="17" name="Image 1" descr="preencoded.png"/>
           <p:cNvPicPr>
             <a:picLocks noChangeAspect="1"/>
           </p:cNvPicPr>
@@ -12071,7 +12087,7 @@
           </a:solidFill>
           <a:ln w="28575">
             <a:solidFill>
-              <a:srgbClr val="E8A13D"/>
+              <a:srgbClr val="3E9B6E"/>
             </a:solidFill>
             <a:prstDash val="solid"/>
           </a:ln>
@@ -12079,14 +12095,14 @@
       </p:sp>
       <p:pic>
         <p:nvPicPr>
-          <p:cNvPr id="24" name="Image 2" descr="preencoded.png">    </p:cNvPr>
+          <p:cNvPr id="24" name="Image 2" descr="preencoded.png"/>
           <p:cNvPicPr>
             <a:picLocks noChangeAspect="1"/>
           </p:cNvPicPr>
           <p:nvPr/>
         </p:nvPicPr>
         <p:blipFill>
-          <a:blip r:embed="rId3"/>
+          <a:blip r:embed="rId1"/>
           <a:stretch>
             <a:fillRect/>
           </a:stretch>
@@ -12267,24 +12283,53 @@
       </p:sp>
       <p:sp>
         <p:nvSpPr>
-          <p:cNvPr id="30" name="Shape 25"/>
-          <p:cNvSpPr/>
-          <p:nvPr/>
-        </p:nvSpPr>
-        <p:spPr>
-          <a:xfrm>
-            <a:off x="7722108" y="5723001"/>
-            <a:ext cx="173736" cy="173736"/>
+          <p:cNvPr id="9100" name="RingRow8"/>
+          <p:cNvSpPr/>
+          <p:nvPr/>
+        </p:nvSpPr>
+        <p:spPr>
+          <a:xfrm>
+            <a:off x="7680960" y="5681853"/>
+            <a:ext cx="256032" cy="256032"/>
           </a:xfrm>
           <a:prstGeom prst="ellipse">
             <a:avLst/>
           </a:prstGeom>
           <a:solidFill>
-            <a:srgbClr val="0B7698"/>
-          </a:solidFill>
-          <a:ln/>
-        </p:spPr>
-      </p:sp>
+            <a:srgbClr val="FFFFFF"/>
+          </a:solidFill>
+          <a:ln w="28575">
+            <a:solidFill>
+              <a:srgbClr val="3E9B6E"/>
+            </a:solidFill>
+            <a:prstDash val="solid"/>
+          </a:ln>
+        </p:spPr>
+      </p:sp>
+      <p:pic>
+        <p:nvPicPr>
+          <p:cNvPr id="9101" name="CheckRow8" descr="preencoded.png"/>
+          <p:cNvPicPr>
+            <a:picLocks noChangeAspect="1"/>
+          </p:cNvPicPr>
+          <p:nvPr/>
+        </p:nvPicPr>
+        <p:blipFill>
+          <a:blip r:embed="rId1"/>
+          <a:stretch>
+            <a:fillRect/>
+          </a:stretch>
+        </p:blipFill>
+        <p:spPr>
+          <a:xfrm>
+            <a:off x="7731252" y="5732145"/>
+            <a:ext cx="155448" cy="155448"/>
+          </a:xfrm>
+          <a:prstGeom prst="rect">
+            <a:avLst/>
+          </a:prstGeom>
+        </p:spPr>
+      </p:pic>
       <p:sp>
         <p:nvSpPr>
           <p:cNvPr id="31" name="Shape 26"/>
@@ -12345,7 +12390,7 @@
                 <a:ea typeface="Calibri" pitchFamily="34" charset="-122"/>
                 <a:cs typeface="Calibri" pitchFamily="34" charset="-120"/>
               </a:rPr>
-              <a:t>GAIN ATTENDU</a:t>
+              <a:t>GAIN OBTENU</a:t>
             </a:r>
             <a:endParaRPr lang="en-US" sz="1050" dirty="0"/>
           </a:p>
@@ -12821,7 +12866,7 @@
                 <a:ea typeface="Trebuchet MS" pitchFamily="34" charset="-122"/>
                 <a:cs typeface="Trebuchet MS" pitchFamily="34" charset="-120"/>
               </a:rPr>
-              <a:t>Zoneless</a:t>
+              <a:t>Zoneless — préparée (ng serve -c zoneless)</a:t>
             </a:r>
             <a:endParaRPr lang="en-US" sz="1450" dirty="0"/>
           </a:p>
@@ -12985,7 +13030,7 @@
                 <a:ea typeface="Trebuchet MS" pitchFamily="34" charset="-122"/>
                 <a:cs typeface="Trebuchet MS" pitchFamily="34" charset="-120"/>
               </a:rPr>
-              <a:t>Clôture</a:t>
+              <a:t>Clôture — livrée</a:t>
             </a:r>
             <a:endParaRPr lang="en-US" sz="1450" dirty="0"/>
           </a:p>
@@ -13052,7 +13097,7 @@
       </p:sp>
       <p:pic>
         <p:nvPicPr>
-          <p:cNvPr id="15" name="Image 0" descr="preencoded.png">    </p:cNvPr>
+          <p:cNvPr id="15" name="Image 0" descr="preencoded.png"/>
           <p:cNvPicPr>
             <a:picLocks noChangeAspect="1"/>
           </p:cNvPicPr>
@@ -13162,7 +13207,7 @@
       </p:sp>
       <p:pic>
         <p:nvPicPr>
-          <p:cNvPr id="18" name="Image 1" descr="preencoded.png">    </p:cNvPr>
+          <p:cNvPr id="18" name="Image 1" descr="preencoded.png"/>
           <p:cNvPicPr>
             <a:picLocks noChangeAspect="1"/>
           </p:cNvPicPr>
@@ -13242,7 +13287,7 @@
           </a:solidFill>
           <a:ln w="25400">
             <a:solidFill>
-              <a:srgbClr val="DCEAF0"/>
+              <a:srgbClr val="3E9B6E"/>
             </a:solidFill>
             <a:prstDash val="solid"/>
           </a:ln>
@@ -13306,7 +13351,7 @@
           </a:solidFill>
           <a:ln w="25400">
             <a:solidFill>
-              <a:srgbClr val="DCEAF0"/>
+              <a:srgbClr val="3E9B6E"/>
             </a:solidFill>
             <a:prstDash val="solid"/>
           </a:ln>
@@ -13932,7 +13977,7 @@
                 <a:ea typeface="Calibri" pitchFamily="34" charset="-122"/>
                 <a:cs typeface="Calibri" pitchFamily="34" charset="-120"/>
               </a:rPr>
-              <a:t>change detections par timeupdate (phase 7, en cours)</a:t>
+              <a:t>change detections par timeupdate (fait)</a:t>
             </a:r>
             <a:endParaRPr lang="en-US" sz="1100" dirty="0"/>
           </a:p>

</xml_diff>